<commit_message>
chore: update group 1 presentation and add PDF export
</commit_message>
<xml_diff>
--- a/group1-slide.pptx
+++ b/group1-slide.pptx
@@ -114,6 +114,11 @@
       </a:defRPr>
     </a:lvl9pPr>
   </p:defaultTextStyle>
+  <p:extLst>
+    <p:ext uri="{EFAFB233-063F-42B5-8137-9DF3F51BA10A}">
+      <p15:sldGuideLst xmlns:p15="http://schemas.microsoft.com/office/powerpoint/2012/main"/>
+    </p:ext>
+  </p:extLst>
 </p:presentation>
 </file>
 
@@ -942,7 +947,47 @@
                 <a:latin typeface="Segoe UI"/>
                 <a:cs typeface="Segoe UI"/>
               </a:rPr>
-              <a:t>     ·     Tháng 06, năm 2026</a:t>
+              <a:t>     ·     Tháng </a:t>
+            </a:r>
+            <a:r>
+              <a:rPr lang="vi-VN" sz="1300" b="0" i="0" dirty="0" smtClean="0">
+                <a:solidFill>
+                  <a:srgbClr val="5A6B7B"/>
+                </a:solidFill>
+                <a:latin typeface="Segoe UI"/>
+                <a:cs typeface="Segoe UI"/>
+              </a:rPr>
+              <a:t>0</a:t>
+            </a:r>
+            <a:r>
+              <a:rPr lang="en-US" sz="1300" b="0" i="0" dirty="0" smtClean="0">
+                <a:solidFill>
+                  <a:srgbClr val="5A6B7B"/>
+                </a:solidFill>
+                <a:latin typeface="Segoe UI"/>
+                <a:cs typeface="Segoe UI"/>
+              </a:rPr>
+              <a:t>7</a:t>
+            </a:r>
+            <a:r>
+              <a:rPr lang="vi-VN" sz="1300" b="0" i="0" dirty="0" smtClean="0">
+                <a:solidFill>
+                  <a:srgbClr val="5A6B7B"/>
+                </a:solidFill>
+                <a:latin typeface="Segoe UI"/>
+                <a:cs typeface="Segoe UI"/>
+              </a:rPr>
+              <a:t>, </a:t>
+            </a:r>
+            <a:r>
+              <a:rPr lang="vi-VN" sz="1300" b="0" i="0" dirty="0">
+                <a:solidFill>
+                  <a:srgbClr val="5A6B7B"/>
+                </a:solidFill>
+                <a:latin typeface="Segoe UI"/>
+                <a:cs typeface="Segoe UI"/>
+              </a:rPr>
+              <a:t>năm 2026</a:t>
             </a:r>
           </a:p>
         </p:txBody>
@@ -6727,23 +6772,19 @@
           </a:bodyPr>
           <a:lstStyle/>
           <a:p>
-            <a:pPr algn="l">
-              <a:lnSpc>
-                <a:spcPct val="100000"/>
-              </a:lnSpc>
-              <a:spcAft>
-                <a:spcPts val="300"/>
-              </a:spcAft>
-            </a:pPr>
-            <a:r>
-              <a:rPr lang="vi-VN" sz="2500" b="1" i="0" dirty="0">
+            <a:pPr>
+              <a:spcAft>
+                <a:spcPts val="300"/>
+              </a:spcAft>
+            </a:pPr>
+            <a:r>
+              <a:rPr lang="vi-VN" sz="2500" b="1" dirty="0">
                 <a:solidFill>
                   <a:srgbClr val="002B5C"/>
                 </a:solidFill>
-                <a:latin typeface="Segoe UI"/>
-                <a:cs typeface="Segoe UI"/>
-              </a:rPr>
-              <a:t>5 phân hệ trong một giao diện Dark Mode</a:t>
+                <a:cs typeface="Segoe UI"/>
+              </a:rPr>
+              <a:t>5 phân hệ trong một giao diện Editorial Climate Almanac</a:t>
             </a:r>
           </a:p>
         </p:txBody>
@@ -7458,7 +7499,7 @@
           </a:bodyPr>
           <a:lstStyle/>
           <a:p>
-            <a:pPr algn="l">
+            <a:pPr>
               <a:lnSpc>
                 <a:spcPct val="108000"/>
               </a:lnSpc>
@@ -7467,14 +7508,22 @@
               </a:spcAft>
             </a:pPr>
             <a:r>
-              <a:rPr lang="vi-VN" sz="1250" b="0" i="0" dirty="0">
+              <a:rPr lang="vi-VN" sz="1250" dirty="0" smtClean="0">
                 <a:solidFill>
                   <a:srgbClr val="5A6B7B"/>
                 </a:solidFill>
-                <a:latin typeface="Segoe UI"/>
-                <a:cs typeface="Segoe UI"/>
-              </a:rPr>
-              <a:t>Glassmorphism, responsive (CSS Grid); màu chỉ thị: đỏ nóng · xanh lạnh · lam mưa.</a:t>
+                <a:cs typeface="Segoe UI"/>
+              </a:rPr>
+              <a:t>Editorial </a:t>
+            </a:r>
+            <a:r>
+              <a:rPr lang="vi-VN" sz="1250" dirty="0">
+                <a:solidFill>
+                  <a:srgbClr val="5A6B7B"/>
+                </a:solidFill>
+                <a:cs typeface="Segoe UI"/>
+              </a:rPr>
+              <a:t>Climate Almanac — tông sáng, nền giấy ấm, kiểu chữ serif; responsive (CSS Grid). Màu theo vùng miền: teal (Bắc) · hổ phách (Trung) · xanh rừng (Nam); thang nhiệt xanh lạnh → đất nung.</a:t>
             </a:r>
           </a:p>
         </p:txBody>
@@ -7763,30 +7812,6 @@
           </a:p>
         </p:txBody>
       </p:sp>
-      <p:pic>
-        <p:nvPicPr>
-          <p:cNvPr id="154" name="img"/>
-          <p:cNvPicPr>
-            <a:picLocks noChangeAspect="1"/>
-          </p:cNvPicPr>
-          <p:nvPr/>
-        </p:nvPicPr>
-        <p:blipFill>
-          <a:blip r:embed="rId2"/>
-          <a:stretch>
-            <a:fillRect/>
-          </a:stretch>
-        </p:blipFill>
-        <p:spPr>
-          <a:xfrm>
-            <a:off x="548640" y="1600200"/>
-            <a:ext cx="7040880" cy="4224528"/>
-          </a:xfrm>
-          <a:prstGeom prst="rect">
-            <a:avLst/>
-          </a:prstGeom>
-        </p:spPr>
-      </p:pic>
       <p:sp>
         <p:nvSpPr>
           <p:cNvPr id="155" name="t"/>
@@ -8163,6 +8188,36 @@
           </a:p>
         </p:txBody>
       </p:sp>
+      <p:pic>
+        <p:nvPicPr>
+          <p:cNvPr id="2" name="Picture 1"/>
+          <p:cNvPicPr>
+            <a:picLocks noChangeAspect="1"/>
+          </p:cNvPicPr>
+          <p:nvPr/>
+        </p:nvPicPr>
+        <p:blipFill>
+          <a:blip r:embed="rId2">
+            <a:extLst>
+              <a:ext uri="{28A0092B-C50C-407E-A947-70E740481C1C}">
+                <a14:useLocalDpi xmlns:a14="http://schemas.microsoft.com/office/drawing/2010/main" val="0"/>
+              </a:ext>
+            </a:extLst>
+          </a:blip>
+          <a:stretch>
+            <a:fillRect/>
+          </a:stretch>
+        </p:blipFill>
+        <p:spPr>
+          <a:xfrm>
+            <a:off x="548640" y="1377086"/>
+            <a:ext cx="7178040" cy="4398270"/>
+          </a:xfrm>
+          <a:prstGeom prst="rect">
+            <a:avLst/>
+          </a:prstGeom>
+        </p:spPr>
+      </p:pic>
     </p:spTree>
   </p:cSld>
   <p:clrMapOvr>
@@ -10569,8 +10624,8 @@
         </p:nvSpPr>
         <p:spPr>
           <a:xfrm>
-            <a:off x="548640" y="3794760"/>
-            <a:ext cx="3520440" cy="1737360"/>
+            <a:off x="548639" y="3794760"/>
+            <a:ext cx="2561811" cy="1737360"/>
           </a:xfrm>
           <a:prstGeom prst="roundRect">
             <a:avLst/>
@@ -10601,7 +10656,7 @@
         <p:spPr>
           <a:xfrm>
             <a:off x="713232" y="3922776"/>
-            <a:ext cx="3191256" cy="365760"/>
+            <a:ext cx="2322265" cy="365760"/>
           </a:xfrm>
           <a:prstGeom prst="rect">
             <a:avLst/>
@@ -10644,7 +10699,7 @@
         <p:spPr>
           <a:xfrm>
             <a:off x="713232" y="4343400"/>
-            <a:ext cx="3191256" cy="1097280"/>
+            <a:ext cx="2322265" cy="1097280"/>
           </a:xfrm>
           <a:prstGeom prst="rect">
             <a:avLst/>
@@ -10686,8 +10741,8 @@
         </p:nvSpPr>
         <p:spPr>
           <a:xfrm>
-            <a:off x="4279392" y="3794760"/>
-            <a:ext cx="3520440" cy="1737360"/>
+            <a:off x="3275044" y="3813048"/>
+            <a:ext cx="2578607" cy="1737360"/>
           </a:xfrm>
           <a:prstGeom prst="roundRect">
             <a:avLst/>
@@ -10717,8 +10772,8 @@
         </p:nvSpPr>
         <p:spPr>
           <a:xfrm>
-            <a:off x="4443984" y="3922776"/>
-            <a:ext cx="3191256" cy="365760"/>
+            <a:off x="3416411" y="3941064"/>
+            <a:ext cx="2337491" cy="365760"/>
           </a:xfrm>
           <a:prstGeom prst="rect">
             <a:avLst/>
@@ -10760,8 +10815,8 @@
         </p:nvSpPr>
         <p:spPr>
           <a:xfrm>
-            <a:off x="4443984" y="4343400"/>
-            <a:ext cx="3191256" cy="1097280"/>
+            <a:off x="3416411" y="4361688"/>
+            <a:ext cx="2337491" cy="1097280"/>
           </a:xfrm>
           <a:prstGeom prst="rect">
             <a:avLst/>
@@ -10803,8 +10858,8 @@
         </p:nvSpPr>
         <p:spPr>
           <a:xfrm>
-            <a:off x="8010144" y="3794760"/>
-            <a:ext cx="3520440" cy="1737360"/>
+            <a:off x="6018244" y="3794760"/>
+            <a:ext cx="2595403" cy="1737360"/>
           </a:xfrm>
           <a:prstGeom prst="roundRect">
             <a:avLst/>
@@ -10834,8 +10889,8 @@
         </p:nvSpPr>
         <p:spPr>
           <a:xfrm>
-            <a:off x="8174736" y="3922776"/>
-            <a:ext cx="3191256" cy="365760"/>
+            <a:off x="6127120" y="3922776"/>
+            <a:ext cx="2352716" cy="365760"/>
           </a:xfrm>
           <a:prstGeom prst="rect">
             <a:avLst/>
@@ -10877,8 +10932,8 @@
         </p:nvSpPr>
         <p:spPr>
           <a:xfrm>
-            <a:off x="8174736" y="4343400"/>
-            <a:ext cx="3191256" cy="1097280"/>
+            <a:off x="6127120" y="4343400"/>
+            <a:ext cx="2352716" cy="1097280"/>
           </a:xfrm>
           <a:prstGeom prst="rect">
             <a:avLst/>
@@ -11023,6 +11078,140 @@
                 <a:cs typeface="Segoe UI"/>
               </a:rPr>
               <a:t>9</a:t>
+            </a:r>
+          </a:p>
+        </p:txBody>
+      </p:sp>
+      <p:sp>
+        <p:nvSpPr>
+          <p:cNvPr id="39" name="s"/>
+          <p:cNvSpPr/>
+          <p:nvPr/>
+        </p:nvSpPr>
+        <p:spPr>
+          <a:xfrm>
+            <a:off x="8778239" y="3785616"/>
+            <a:ext cx="2720869" cy="1737360"/>
+          </a:xfrm>
+          <a:prstGeom prst="roundRect">
+            <a:avLst/>
+          </a:prstGeom>
+          <a:solidFill>
+            <a:srgbClr val="FFFFFF"/>
+          </a:solidFill>
+          <a:ln w="12700">
+            <a:solidFill>
+              <a:srgbClr val="D7E3EF"/>
+            </a:solidFill>
+          </a:ln>
+        </p:spPr>
+        <p:txBody>
+          <a:bodyPr/>
+          <a:lstStyle/>
+          <a:p>
+            <a:endParaRPr/>
+          </a:p>
+        </p:txBody>
+      </p:sp>
+      <p:sp>
+        <p:nvSpPr>
+          <p:cNvPr id="40" name="t"/>
+          <p:cNvSpPr txBox="1"/>
+          <p:nvPr/>
+        </p:nvSpPr>
+        <p:spPr>
+          <a:xfrm>
+            <a:off x="8868067" y="3913632"/>
+            <a:ext cx="2466450" cy="365760"/>
+          </a:xfrm>
+          <a:prstGeom prst="rect">
+            <a:avLst/>
+          </a:prstGeom>
+          <a:noFill/>
+        </p:spPr>
+        <p:txBody>
+          <a:bodyPr wrap="square" lIns="63500" tIns="38100" rIns="63500" bIns="38100" anchor="t">
+            <a:normAutofit/>
+          </a:bodyPr>
+          <a:lstStyle/>
+          <a:p>
+            <a:pPr>
+              <a:spcAft>
+                <a:spcPts val="300"/>
+              </a:spcAft>
+            </a:pPr>
+            <a:r>
+              <a:rPr lang="vi-VN" sz="1500" b="1" dirty="0">
+                <a:solidFill>
+                  <a:srgbClr val="005BA1"/>
+                </a:solidFill>
+                <a:cs typeface="Segoe UI"/>
+              </a:rPr>
+              <a:t>Guard cho Python</a:t>
+            </a:r>
+          </a:p>
+          <a:p>
+            <a:pPr>
+              <a:spcAft>
+                <a:spcPts val="300"/>
+              </a:spcAft>
+            </a:pPr>
+            <a:endParaRPr lang="vi-VN" sz="1500" b="1" dirty="0">
+              <a:solidFill>
+                <a:srgbClr val="005BA1"/>
+              </a:solidFill>
+              <a:cs typeface="Segoe UI"/>
+            </a:endParaRPr>
+          </a:p>
+        </p:txBody>
+      </p:sp>
+      <p:sp>
+        <p:nvSpPr>
+          <p:cNvPr id="41" name="t"/>
+          <p:cNvSpPr txBox="1"/>
+          <p:nvPr/>
+        </p:nvSpPr>
+        <p:spPr>
+          <a:xfrm>
+            <a:off x="8868067" y="4334256"/>
+            <a:ext cx="2466450" cy="1097280"/>
+          </a:xfrm>
+          <a:prstGeom prst="rect">
+            <a:avLst/>
+          </a:prstGeom>
+          <a:noFill/>
+        </p:spPr>
+        <p:txBody>
+          <a:bodyPr wrap="square" lIns="63500" tIns="38100" rIns="63500" bIns="38100" anchor="t">
+            <a:normAutofit/>
+          </a:bodyPr>
+          <a:lstStyle/>
+          <a:p>
+            <a:pPr>
+              <a:lnSpc>
+                <a:spcPct val="108000"/>
+              </a:lnSpc>
+              <a:spcAft>
+                <a:spcPts val="300"/>
+              </a:spcAft>
+            </a:pPr>
+            <a:r>
+              <a:rPr lang="vi-VN" sz="1250" dirty="0" smtClean="0">
+                <a:solidFill>
+                  <a:srgbClr val="5A6B7B"/>
+                </a:solidFill>
+                <a:cs typeface="Segoe UI"/>
+              </a:rPr>
+              <a:t>Phân </a:t>
+            </a:r>
+            <a:r>
+              <a:rPr lang="vi-VN" sz="1250" dirty="0">
+                <a:solidFill>
+                  <a:srgbClr val="5A6B7B"/>
+                </a:solidFill>
+                <a:cs typeface="Segoe UI"/>
+              </a:rPr>
+              <a:t>tích cú pháp AST, chặn import/eval/exec và đọc/ghi tệp.</a:t>
             </a:r>
           </a:p>
         </p:txBody>

</xml_diff>